<commit_message>
ECE 407 Fall 2026: lectures 4-8, new demos, syllabus links
- Add block-cipher demos (AES diffusion, DES avalanche, SPN lab,
  differential attack, modes of operation) and the Ladder of Nagara game
- Add Lecture 8 interactive slides, lecture PDFs and HW1
- Syllabus: new Lectures and Homework section, updated demo count,
  fix TA mailto link
- Archive Fall 2025 course under 407-9876339-2025; ece407/index.html
  now forwards to the Fall 2026 syllabus; fix teaching.html link
- Add Join page; research.html venue update

Co-Authored-By: Claude Opus 5.5 (1M context) <noreply@anthropic.com>
</commit_message>
<xml_diff>
--- a/ece407/407-4562870-2026/lec4.pptx
+++ b/ece407/407-4562870-2026/lec4.pptx
@@ -34600,8 +34600,8 @@
           <a:chExt cx="0" cy="0"/>
         </a:xfrm>
       </p:grpSpPr>
-      <mc:AlternateContent xmlns:mc="http://schemas.openxmlformats.org/markup-compatibility/2006" xmlns:a14="http://schemas.microsoft.com/office/drawing/2010/main">
-        <mc:Choice Requires="a14">
+      <mc:AlternateContent xmlns:mc="http://schemas.openxmlformats.org/markup-compatibility/2006">
+        <mc:Choice xmlns:a14="http://schemas.microsoft.com/office/drawing/2010/main" Requires="a14">
           <p:sp>
             <p:nvSpPr>
               <p:cNvPr id="3" name="Content Placeholder 2">
@@ -34633,7 +34633,11 @@
                 </a:pPr>
                 <a:r>
                   <a:rPr lang="en-US" dirty="0"/>
-                  <a:t>Lemma 3: (2.5 in the book) </a:t>
+                  <a:t>Lemma</a:t>
+                </a:r>
+                <a:r>
+                  <a:rPr lang="en-US" altLang="zh-CN" dirty="0"/>
+                  <a:t>:</a:t>
                 </a:r>
               </a:p>
               <a:p>
@@ -35131,7 +35135,7 @@
             </p:txBody>
           </p:sp>
         </mc:Choice>
-        <mc:Fallback xmlns="">
+        <mc:Fallback>
           <p:sp>
             <p:nvSpPr>
               <p:cNvPr id="3" name="Content Placeholder 2">
@@ -35156,7 +35160,7 @@
               <a:blipFill>
                 <a:blip r:embed="rId2"/>
                 <a:stretch>
-                  <a:fillRect l="-1159" t="-2016"/>
+                  <a:fillRect l="-1327" t="-1860"/>
                 </a:stretch>
               </a:blipFill>
             </p:spPr>

</xml_diff>